<commit_message>
Agenda, Lecture and react component intro update
</commit_message>
<xml_diff>
--- a/docs/slides/DMIT2008-Week3-Day1-react-new.pptx
+++ b/docs/slides/DMIT2008-Week3-Day1-react-new.pptx
@@ -282,6 +282,11 @@
       </a:defRPr>
     </a:lvl9pPr>
   </p:defaultTextStyle>
+  <p:extLst>
+    <p:ext uri="{EFAFB233-063F-42B5-8137-9DF3F51BA10A}">
+      <p15:sldGuideLst xmlns:p15="http://schemas.microsoft.com/office/powerpoint/2012/main"/>
+    </p:ext>
+  </p:extLst>
 </p:presentation>
 </file>
 
@@ -1379,7 +1384,7 @@
         </p:nvSpPr>
         <p:spPr>
           <a:xfrm>
-            <a:off x="381300" y="685800"/>
+            <a:off x="381000" y="685800"/>
             <a:ext cx="6096000" cy="3429000"/>
           </a:xfrm>
           <a:custGeom>
@@ -1442,7 +1447,30 @@
               </a:spcAft>
               <a:buNone/>
             </a:pPr>
-            <a:endParaRPr/>
+            <a:r>
+              <a:rPr lang="en-US" dirty="0"/>
+              <a:t>JSX is an HTML like syntax that is value returned from every </a:t>
+            </a:r>
+            <a:r>
+              <a:rPr lang="en-US"/>
+              <a:t>React Component.</a:t>
+            </a:r>
+          </a:p>
+          <a:p>
+            <a:pPr marL="0" lvl="0" indent="0" algn="l" rtl="0">
+              <a:spcBef>
+                <a:spcPts val="0"/>
+              </a:spcBef>
+              <a:spcAft>
+                <a:spcPts val="0"/>
+              </a:spcAft>
+              <a:buNone/>
+            </a:pPr>
+            <a:r>
+              <a:rPr lang="en-US" dirty="0"/>
+              <a:t>Components are special JS functions that we can use inside our JSX. This is super powerful because we’re kind of making our own html syntax.</a:t>
+            </a:r>
+            <a:endParaRPr dirty="0"/>
           </a:p>
         </p:txBody>
       </p:sp>
@@ -8775,10 +8803,10 @@
               <a:buNone/>
             </a:pPr>
             <a:r>
-              <a:rPr lang="en" sz="1400"/>
+              <a:rPr lang="en" sz="1400" dirty="0"/>
               <a:t>Components could be pages in your app, some type of piece of functionality in your app, or some type of layout/styling.</a:t>
             </a:r>
-            <a:endParaRPr sz="1400"/>
+            <a:endParaRPr sz="1400" dirty="0"/>
           </a:p>
           <a:p>
             <a:pPr marL="0" lvl="0" indent="0" algn="l" rtl="0">
@@ -8791,10 +8819,10 @@
               <a:buNone/>
             </a:pPr>
             <a:r>
-              <a:rPr lang="en" sz="1400"/>
+              <a:rPr lang="en" sz="1400" dirty="0"/>
               <a:t>Types of Component</a:t>
             </a:r>
-            <a:endParaRPr sz="1400"/>
+            <a:endParaRPr sz="1400" dirty="0"/>
           </a:p>
           <a:p>
             <a:pPr marL="457200" lvl="0" indent="-317500" algn="l" rtl="0">
@@ -8808,10 +8836,10 @@
               <a:buChar char="●"/>
             </a:pPr>
             <a:r>
-              <a:rPr lang="en" sz="1400"/>
+              <a:rPr lang="en" sz="1400" dirty="0"/>
               <a:t>Class Based Components</a:t>
             </a:r>
-            <a:endParaRPr sz="1400"/>
+            <a:endParaRPr sz="1400" dirty="0"/>
           </a:p>
           <a:p>
             <a:pPr marL="914400" lvl="1" indent="-317500" algn="l" rtl="0">
@@ -8825,10 +8853,10 @@
               <a:buChar char="○"/>
             </a:pPr>
             <a:r>
-              <a:rPr lang="en"/>
+              <a:rPr lang="en" dirty="0"/>
               <a:t>Class based components are what react what originally written with. </a:t>
             </a:r>
-            <a:endParaRPr/>
+            <a:endParaRPr dirty="0"/>
           </a:p>
           <a:p>
             <a:pPr marL="457200" lvl="0" indent="-317500" algn="l" rtl="0">
@@ -8842,10 +8870,10 @@
               <a:buChar char="●"/>
             </a:pPr>
             <a:r>
-              <a:rPr lang="en" sz="1400"/>
+              <a:rPr lang="en" sz="1400" dirty="0"/>
               <a:t>Functionally Based Components (hooks)</a:t>
             </a:r>
-            <a:endParaRPr sz="1400"/>
+            <a:endParaRPr sz="1400" dirty="0"/>
           </a:p>
           <a:p>
             <a:pPr marL="914400" lvl="1" indent="-317500" algn="l" rtl="0">
@@ -8859,10 +8887,10 @@
               <a:buChar char="○"/>
             </a:pPr>
             <a:r>
-              <a:rPr lang="en"/>
+              <a:rPr lang="en" dirty="0"/>
               <a:t>There are the newer* way to write components in react, also it is encouraged to write components in this way. As well this saves many lines of code.</a:t>
             </a:r>
-            <a:endParaRPr/>
+            <a:endParaRPr dirty="0"/>
           </a:p>
           <a:p>
             <a:pPr marL="0" lvl="0" indent="0" algn="l" rtl="0">
@@ -8875,11 +8903,11 @@
               <a:buNone/>
             </a:pPr>
             <a:r>
-              <a:rPr lang="en" sz="1400"/>
+              <a:rPr lang="en" sz="1400" dirty="0"/>
               <a:t>Note: While React encourages users to use functionally based components </a:t>
             </a:r>
             <a:r>
-              <a:rPr lang="en" sz="1400" u="sng">
+              <a:rPr lang="en" sz="1400" u="sng" dirty="0">
                 <a:solidFill>
                   <a:schemeClr val="hlink"/>
                 </a:solidFill>
@@ -8888,10 +8916,10 @@
               <a:t>it does not have any plans to retire Class based components</a:t>
             </a:r>
             <a:r>
-              <a:rPr lang="en" sz="1400"/>
+              <a:rPr lang="en" sz="1400" dirty="0"/>
               <a:t>. Although since we're learning from the start then we're going to mainly focus on functional based components.</a:t>
             </a:r>
-            <a:endParaRPr sz="1400"/>
+            <a:endParaRPr sz="1400" dirty="0"/>
           </a:p>
         </p:txBody>
       </p:sp>
@@ -9378,10 +9406,10 @@
               <a:buNone/>
             </a:pPr>
             <a:r>
-              <a:rPr lang="en"/>
+              <a:rPr lang="en" dirty="0"/>
               <a:t>We've seen that with React.createElement we can create elements in React.</a:t>
             </a:r>
-            <a:endParaRPr/>
+            <a:endParaRPr dirty="0"/>
           </a:p>
           <a:p>
             <a:pPr marL="0" lvl="0" indent="0" algn="l" rtl="0">
@@ -9394,10 +9422,10 @@
               <a:buNone/>
             </a:pPr>
             <a:r>
-              <a:rPr lang="en"/>
+              <a:rPr lang="en" dirty="0"/>
               <a:t>You can probably is going to be a cumbersome if you have to write React.createElement everytime.</a:t>
             </a:r>
-            <a:endParaRPr/>
+            <a:endParaRPr dirty="0"/>
           </a:p>
           <a:p>
             <a:pPr marL="0" lvl="0" indent="0" algn="l" rtl="0">
@@ -9410,10 +9438,10 @@
               <a:buNone/>
             </a:pPr>
             <a:r>
-              <a:rPr lang="en"/>
+              <a:rPr lang="en" dirty="0"/>
               <a:t>JSX is a template(ish) language that allows you to write what feels like HTML and Javascript together. Under the hood babel is converting all of the elements to "React.createElement" anyways, but more on that later.</a:t>
             </a:r>
-            <a:endParaRPr/>
+            <a:endParaRPr dirty="0"/>
           </a:p>
           <a:p>
             <a:pPr marL="0" lvl="0" indent="0" algn="l" rtl="0">
@@ -9426,10 +9454,10 @@
               <a:buNone/>
             </a:pPr>
             <a:r>
-              <a:rPr lang="en"/>
+              <a:rPr lang="en" dirty="0"/>
               <a:t>Let’s go take a look at an example of what it looks like.</a:t>
             </a:r>
-            <a:endParaRPr/>
+            <a:endParaRPr dirty="0"/>
           </a:p>
           <a:p>
             <a:pPr marL="0" lvl="0" indent="0" algn="l" rtl="0">
@@ -9441,7 +9469,7 @@
               </a:spcAft>
               <a:buNone/>
             </a:pPr>
-            <a:endParaRPr/>
+            <a:endParaRPr dirty="0"/>
           </a:p>
         </p:txBody>
       </p:sp>
@@ -9547,7 +9575,7 @@
               <a:buNone/>
             </a:pPr>
             <a:r>
-              <a:rPr lang="en" sz="1150">
+              <a:rPr lang="en" sz="1150" dirty="0">
                 <a:solidFill>
                   <a:srgbClr val="4DD0E1"/>
                 </a:solidFill>
@@ -9559,7 +9587,7 @@
               <a:t>const</a:t>
             </a:r>
             <a:r>
-              <a:rPr lang="en" sz="1150">
+              <a:rPr lang="en" sz="1150" dirty="0">
                 <a:solidFill>
                   <a:srgbClr val="ECEFF1"/>
                 </a:solidFill>
@@ -9570,7 +9598,7 @@
               </a:rPr>
               <a:t> helloKitties = () =&gt; {</a:t>
             </a:r>
-            <a:endParaRPr sz="1150">
+            <a:endParaRPr sz="1150" dirty="0">
               <a:solidFill>
                 <a:srgbClr val="ECEFF1"/>
               </a:solidFill>
@@ -9591,7 +9619,7 @@
               <a:buNone/>
             </a:pPr>
             <a:r>
-              <a:rPr lang="en" sz="1150">
+              <a:rPr lang="en" sz="1150" dirty="0">
                 <a:solidFill>
                   <a:srgbClr val="ECEFF1"/>
                 </a:solidFill>
@@ -9603,7 +9631,7 @@
               <a:t>  </a:t>
             </a:r>
             <a:r>
-              <a:rPr lang="en" sz="1150">
+              <a:rPr lang="en" sz="1150" dirty="0">
                 <a:solidFill>
                   <a:srgbClr val="4DD0E1"/>
                 </a:solidFill>
@@ -9615,7 +9643,7 @@
               <a:t>return</a:t>
             </a:r>
             <a:r>
-              <a:rPr lang="en" sz="1150">
+              <a:rPr lang="en" sz="1150" dirty="0">
                 <a:solidFill>
                   <a:srgbClr val="ECEFF1"/>
                 </a:solidFill>
@@ -9626,7 +9654,7 @@
               </a:rPr>
               <a:t> &lt;div&gt;</a:t>
             </a:r>
-            <a:endParaRPr sz="1150">
+            <a:endParaRPr sz="1150" dirty="0">
               <a:solidFill>
                 <a:srgbClr val="ECEFF1"/>
               </a:solidFill>
@@ -9647,7 +9675,7 @@
               <a:buNone/>
             </a:pPr>
             <a:r>
-              <a:rPr lang="en" sz="1150">
+              <a:rPr lang="en" sz="1150" dirty="0">
                 <a:solidFill>
                   <a:srgbClr val="ECEFF1"/>
                 </a:solidFill>
@@ -9659,7 +9687,7 @@
               <a:t>    &lt;</a:t>
             </a:r>
             <a:r>
-              <a:rPr lang="en" sz="1150">
+              <a:rPr lang="en" sz="1150" dirty="0">
                 <a:solidFill>
                   <a:srgbClr val="CE93D8"/>
                 </a:solidFill>
@@ -9671,7 +9699,7 @@
               <a:t>Cat</a:t>
             </a:r>
             <a:r>
-              <a:rPr lang="en" sz="1150">
+              <a:rPr lang="en" sz="1150" dirty="0">
                 <a:solidFill>
                   <a:srgbClr val="ECEFF1"/>
                 </a:solidFill>
@@ -9683,7 +9711,7 @@
               <a:t> cat=</a:t>
             </a:r>
             <a:r>
-              <a:rPr lang="en" sz="1150">
+              <a:rPr lang="en" sz="1150" dirty="0">
                 <a:solidFill>
                   <a:srgbClr val="9CCC65"/>
                 </a:solidFill>
@@ -9695,7 +9723,7 @@
               <a:t>"MarshMallow"</a:t>
             </a:r>
             <a:r>
-              <a:rPr lang="en" sz="1150">
+              <a:rPr lang="en" sz="1150" dirty="0">
                 <a:solidFill>
                   <a:srgbClr val="ECEFF1"/>
                 </a:solidFill>
@@ -9707,7 +9735,7 @@
               <a:t> color=</a:t>
             </a:r>
             <a:r>
-              <a:rPr lang="en" sz="1150">
+              <a:rPr lang="en" sz="1150" dirty="0">
                 <a:solidFill>
                   <a:srgbClr val="9CCC65"/>
                 </a:solidFill>
@@ -9719,7 +9747,7 @@
               <a:t>"white"</a:t>
             </a:r>
             <a:r>
-              <a:rPr lang="en" sz="1150">
+              <a:rPr lang="en" sz="1150" dirty="0">
                 <a:solidFill>
                   <a:srgbClr val="ECEFF1"/>
                 </a:solidFill>
@@ -9730,7 +9758,7 @@
               </a:rPr>
               <a:t>/&gt;</a:t>
             </a:r>
-            <a:endParaRPr sz="1150">
+            <a:endParaRPr sz="1150" dirty="0">
               <a:solidFill>
                 <a:srgbClr val="ECEFF1"/>
               </a:solidFill>
@@ -9751,7 +9779,7 @@
               <a:buNone/>
             </a:pPr>
             <a:r>
-              <a:rPr lang="en" sz="1150">
+              <a:rPr lang="en" sz="1150" dirty="0">
                 <a:solidFill>
                   <a:srgbClr val="ECEFF1"/>
                 </a:solidFill>
@@ -9763,7 +9791,7 @@
               <a:t>    &lt;</a:t>
             </a:r>
             <a:r>
-              <a:rPr lang="en" sz="1150">
+              <a:rPr lang="en" sz="1150" dirty="0">
                 <a:solidFill>
                   <a:srgbClr val="CE93D8"/>
                 </a:solidFill>
@@ -9775,7 +9803,7 @@
               <a:t>Cat</a:t>
             </a:r>
             <a:r>
-              <a:rPr lang="en" sz="1150">
+              <a:rPr lang="en" sz="1150" dirty="0">
                 <a:solidFill>
                   <a:srgbClr val="ECEFF1"/>
                 </a:solidFill>
@@ -9787,7 +9815,7 @@
               <a:t> cat=</a:t>
             </a:r>
             <a:r>
-              <a:rPr lang="en" sz="1150">
+              <a:rPr lang="en" sz="1150" dirty="0">
                 <a:solidFill>
                   <a:srgbClr val="9CCC65"/>
                 </a:solidFill>
@@ -9799,7 +9827,7 @@
               <a:t>"Gambit"</a:t>
             </a:r>
             <a:r>
-              <a:rPr lang="en" sz="1150">
+              <a:rPr lang="en" sz="1150" dirty="0">
                 <a:solidFill>
                   <a:srgbClr val="ECEFF1"/>
                 </a:solidFill>
@@ -9811,7 +9839,7 @@
               <a:t> color=</a:t>
             </a:r>
             <a:r>
-              <a:rPr lang="en" sz="1150">
+              <a:rPr lang="en" sz="1150" dirty="0">
                 <a:solidFill>
                   <a:srgbClr val="9CCC65"/>
                 </a:solidFill>
@@ -9823,7 +9851,7 @@
               <a:t>"white"</a:t>
             </a:r>
             <a:r>
-              <a:rPr lang="en" sz="1150">
+              <a:rPr lang="en" sz="1150" dirty="0">
                 <a:solidFill>
                   <a:srgbClr val="ECEFF1"/>
                 </a:solidFill>
@@ -9834,7 +9862,7 @@
               </a:rPr>
               <a:t>/&gt;</a:t>
             </a:r>
-            <a:endParaRPr sz="1150">
+            <a:endParaRPr sz="1150" dirty="0">
               <a:solidFill>
                 <a:srgbClr val="ECEFF1"/>
               </a:solidFill>
@@ -9855,7 +9883,7 @@
               <a:buNone/>
             </a:pPr>
             <a:r>
-              <a:rPr lang="en" sz="1150">
+              <a:rPr lang="en" sz="1150" dirty="0">
                 <a:solidFill>
                   <a:srgbClr val="ECEFF1"/>
                 </a:solidFill>
@@ -9867,7 +9895,7 @@
               <a:t>    &lt;</a:t>
             </a:r>
             <a:r>
-              <a:rPr lang="en" sz="1150">
+              <a:rPr lang="en" sz="1150" dirty="0">
                 <a:solidFill>
                   <a:srgbClr val="CE93D8"/>
                 </a:solidFill>
@@ -9879,7 +9907,7 @@
               <a:t>Cat</a:t>
             </a:r>
             <a:r>
-              <a:rPr lang="en" sz="1150">
+              <a:rPr lang="en" sz="1150" dirty="0">
                 <a:solidFill>
                   <a:srgbClr val="ECEFF1"/>
                 </a:solidFill>
@@ -9891,7 +9919,7 @@
               <a:t> cat=</a:t>
             </a:r>
             <a:r>
-              <a:rPr lang="en" sz="1150">
+              <a:rPr lang="en" sz="1150" dirty="0">
                 <a:solidFill>
                   <a:srgbClr val="9CCC65"/>
                 </a:solidFill>
@@ -9903,7 +9931,7 @@
               <a:t>"Ghost"</a:t>
             </a:r>
             <a:r>
-              <a:rPr lang="en" sz="1150">
+              <a:rPr lang="en" sz="1150" dirty="0">
                 <a:solidFill>
                   <a:srgbClr val="ECEFF1"/>
                 </a:solidFill>
@@ -9915,7 +9943,7 @@
               <a:t> color=</a:t>
             </a:r>
             <a:r>
-              <a:rPr lang="en" sz="1150">
+              <a:rPr lang="en" sz="1150" dirty="0">
                 <a:solidFill>
                   <a:srgbClr val="9CCC65"/>
                 </a:solidFill>
@@ -9927,7 +9955,7 @@
               <a:t>"white"</a:t>
             </a:r>
             <a:r>
-              <a:rPr lang="en" sz="1150">
+              <a:rPr lang="en" sz="1150" dirty="0">
                 <a:solidFill>
                   <a:srgbClr val="ECEFF1"/>
                 </a:solidFill>
@@ -9938,7 +9966,7 @@
               </a:rPr>
               <a:t>/&gt;</a:t>
             </a:r>
-            <a:endParaRPr sz="1150">
+            <a:endParaRPr sz="1150" dirty="0">
               <a:solidFill>
                 <a:srgbClr val="ECEFF1"/>
               </a:solidFill>
@@ -9959,7 +9987,7 @@
               <a:buNone/>
             </a:pPr>
             <a:r>
-              <a:rPr lang="en" sz="1150">
+              <a:rPr lang="en" sz="1150" dirty="0">
                 <a:solidFill>
                   <a:srgbClr val="ECEFF1"/>
                 </a:solidFill>
@@ -9970,7 +9998,7 @@
               </a:rPr>
               <a:t>  &lt;/div&gt;;</a:t>
             </a:r>
-            <a:endParaRPr sz="1150">
+            <a:endParaRPr sz="1150" dirty="0">
               <a:solidFill>
                 <a:srgbClr val="ECEFF1"/>
               </a:solidFill>
@@ -9994,7 +10022,7 @@
               <a:buNone/>
             </a:pPr>
             <a:r>
-              <a:rPr lang="en" sz="1150">
+              <a:rPr lang="en" sz="1150" dirty="0">
                 <a:solidFill>
                   <a:srgbClr val="ECEFF1"/>
                 </a:solidFill>
@@ -10005,7 +10033,7 @@
               </a:rPr>
               <a:t>}</a:t>
             </a:r>
-            <a:endParaRPr sz="1150">
+            <a:endParaRPr sz="1150" dirty="0">
               <a:solidFill>
                 <a:srgbClr val="ECEFF1"/>
               </a:solidFill>
@@ -11196,7 +11224,7 @@
               <a:buNone/>
             </a:pPr>
             <a:r>
-              <a:rPr lang="en" sz="1150">
+              <a:rPr lang="en" sz="1150" dirty="0">
                 <a:solidFill>
                   <a:srgbClr val="4DD0E1"/>
                 </a:solidFill>
@@ -11208,7 +11236,7 @@
               <a:t>class</a:t>
             </a:r>
             <a:r>
-              <a:rPr lang="en" sz="1150">
+              <a:rPr lang="en" sz="1150" dirty="0">
                 <a:solidFill>
                   <a:srgbClr val="ECEFF1"/>
                 </a:solidFill>
@@ -11220,7 +11248,7 @@
               <a:t> </a:t>
             </a:r>
             <a:r>
-              <a:rPr lang="en" sz="1150">
+              <a:rPr lang="en" sz="1150" dirty="0">
                 <a:solidFill>
                   <a:srgbClr val="CE93D8"/>
                 </a:solidFill>
@@ -11232,7 +11260,7 @@
               <a:t>HelloWorld</a:t>
             </a:r>
             <a:r>
-              <a:rPr lang="en" sz="1150">
+              <a:rPr lang="en" sz="1150" dirty="0">
                 <a:solidFill>
                   <a:srgbClr val="ECEFF1"/>
                 </a:solidFill>
@@ -11244,7 +11272,7 @@
               <a:t> extends </a:t>
             </a:r>
             <a:r>
-              <a:rPr lang="en" sz="1150">
+              <a:rPr lang="en" sz="1150" dirty="0">
                 <a:solidFill>
                   <a:srgbClr val="CE93D8"/>
                 </a:solidFill>
@@ -11256,7 +11284,7 @@
               <a:t>React</a:t>
             </a:r>
             <a:r>
-              <a:rPr lang="en" sz="1150">
+              <a:rPr lang="en" sz="1150" dirty="0">
                 <a:solidFill>
                   <a:srgbClr val="ECEFF1"/>
                 </a:solidFill>
@@ -11268,7 +11296,7 @@
               <a:t>.</a:t>
             </a:r>
             <a:r>
-              <a:rPr lang="en" sz="1150">
+              <a:rPr lang="en" sz="1150" dirty="0">
                 <a:solidFill>
                   <a:srgbClr val="CE93D8"/>
                 </a:solidFill>
@@ -11280,7 +11308,7 @@
               <a:t>Component</a:t>
             </a:r>
             <a:r>
-              <a:rPr lang="en" sz="1150">
+              <a:rPr lang="en" sz="1150" dirty="0">
                 <a:solidFill>
                   <a:srgbClr val="ECEFF1"/>
                 </a:solidFill>
@@ -11291,7 +11319,7 @@
               </a:rPr>
               <a:t> {</a:t>
             </a:r>
-            <a:endParaRPr sz="1150">
+            <a:endParaRPr sz="1150" dirty="0">
               <a:solidFill>
                 <a:srgbClr val="ECEFF1"/>
               </a:solidFill>
@@ -11312,7 +11340,7 @@
               <a:buNone/>
             </a:pPr>
             <a:r>
-              <a:rPr lang="en" sz="1150">
+              <a:rPr lang="en" sz="1150" dirty="0">
                 <a:solidFill>
                   <a:srgbClr val="ECEFF1"/>
                 </a:solidFill>
@@ -11323,7 +11351,7 @@
               </a:rPr>
               <a:t>  render() {</a:t>
             </a:r>
-            <a:endParaRPr sz="1150">
+            <a:endParaRPr sz="1150" dirty="0">
               <a:solidFill>
                 <a:srgbClr val="ECEFF1"/>
               </a:solidFill>
@@ -11344,7 +11372,7 @@
               <a:buNone/>
             </a:pPr>
             <a:r>
-              <a:rPr lang="en" sz="1150">
+              <a:rPr lang="en" sz="1150" dirty="0">
                 <a:solidFill>
                   <a:srgbClr val="ECEFF1"/>
                 </a:solidFill>
@@ -11356,7 +11384,7 @@
               <a:t>    </a:t>
             </a:r>
             <a:r>
-              <a:rPr lang="en" sz="1150">
+              <a:rPr lang="en" sz="1150" dirty="0">
                 <a:solidFill>
                   <a:srgbClr val="4DD0E1"/>
                 </a:solidFill>
@@ -11368,7 +11396,7 @@
               <a:t>return</a:t>
             </a:r>
             <a:r>
-              <a:rPr lang="en" sz="1150">
+              <a:rPr lang="en" sz="1150" dirty="0">
                 <a:solidFill>
                   <a:srgbClr val="ECEFF1"/>
                 </a:solidFill>
@@ -11379,7 +11407,7 @@
               </a:rPr>
               <a:t> (</a:t>
             </a:r>
-            <a:endParaRPr sz="1150">
+            <a:endParaRPr sz="1150" dirty="0">
               <a:solidFill>
                 <a:srgbClr val="ECEFF1"/>
               </a:solidFill>
@@ -11400,7 +11428,7 @@
               <a:buNone/>
             </a:pPr>
             <a:r>
-              <a:rPr lang="en" sz="1150">
+              <a:rPr lang="en" sz="1150" dirty="0">
                 <a:solidFill>
                   <a:srgbClr val="ECEFF1"/>
                 </a:solidFill>
@@ -11412,7 +11440,7 @@
               <a:t>      &lt;div&gt;</a:t>
             </a:r>
             <a:r>
-              <a:rPr lang="en" sz="1150">
+              <a:rPr lang="en" sz="1150" dirty="0">
                 <a:solidFill>
                   <a:srgbClr val="CE93D8"/>
                 </a:solidFill>
@@ -11424,7 +11452,7 @@
               <a:t>Hello</a:t>
             </a:r>
             <a:r>
-              <a:rPr lang="en" sz="1150">
+              <a:rPr lang="en" sz="1150" dirty="0">
                 <a:solidFill>
                   <a:srgbClr val="ECEFF1"/>
                 </a:solidFill>
@@ -11436,7 +11464,7 @@
               <a:t> </a:t>
             </a:r>
             <a:r>
-              <a:rPr lang="en" sz="1150">
+              <a:rPr lang="en" sz="1150" dirty="0">
                 <a:solidFill>
                   <a:srgbClr val="CE93D8"/>
                 </a:solidFill>
@@ -11448,7 +11476,7 @@
               <a:t>World</a:t>
             </a:r>
             <a:r>
-              <a:rPr lang="en" sz="1150">
+              <a:rPr lang="en" sz="1150" dirty="0">
                 <a:solidFill>
                   <a:srgbClr val="ECEFF1"/>
                 </a:solidFill>
@@ -11459,7 +11487,7 @@
               </a:rPr>
               <a:t>, you seem classy&lt;/div&gt;</a:t>
             </a:r>
-            <a:endParaRPr sz="1150">
+            <a:endParaRPr sz="1150" dirty="0">
               <a:solidFill>
                 <a:srgbClr val="ECEFF1"/>
               </a:solidFill>
@@ -11480,7 +11508,7 @@
               <a:buNone/>
             </a:pPr>
             <a:r>
-              <a:rPr lang="en" sz="1150">
+              <a:rPr lang="en" sz="1150" dirty="0">
                 <a:solidFill>
                   <a:srgbClr val="ECEFF1"/>
                 </a:solidFill>
@@ -11491,7 +11519,7 @@
               </a:rPr>
               <a:t>    );</a:t>
             </a:r>
-            <a:endParaRPr sz="1150">
+            <a:endParaRPr sz="1150" dirty="0">
               <a:solidFill>
                 <a:srgbClr val="ECEFF1"/>
               </a:solidFill>
@@ -11512,7 +11540,7 @@
               <a:buNone/>
             </a:pPr>
             <a:r>
-              <a:rPr lang="en" sz="1150">
+              <a:rPr lang="en" sz="1150" dirty="0">
                 <a:solidFill>
                   <a:srgbClr val="ECEFF1"/>
                 </a:solidFill>
@@ -11523,7 +11551,7 @@
               </a:rPr>
               <a:t>  }</a:t>
             </a:r>
-            <a:endParaRPr sz="1150">
+            <a:endParaRPr sz="1150" dirty="0">
               <a:solidFill>
                 <a:srgbClr val="ECEFF1"/>
               </a:solidFill>
@@ -11547,7 +11575,7 @@
               <a:buNone/>
             </a:pPr>
             <a:r>
-              <a:rPr lang="en" sz="1150">
+              <a:rPr lang="en" sz="1150" dirty="0">
                 <a:solidFill>
                   <a:srgbClr val="ECEFF1"/>
                 </a:solidFill>
@@ -11558,7 +11586,7 @@
               </a:rPr>
               <a:t>}</a:t>
             </a:r>
-            <a:endParaRPr sz="1150">
+            <a:endParaRPr sz="1150" dirty="0">
               <a:solidFill>
                 <a:srgbClr val="ECEFF1"/>
               </a:solidFill>
@@ -14966,10 +14994,10 @@
               <a:buNone/>
             </a:pPr>
             <a:r>
-              <a:rPr lang="en" sz="1200"/>
+              <a:rPr lang="en" sz="1200" dirty="0"/>
               <a:t>Next.js is a framework that uses React.js at its’ core, but adds a lot of features that are great for development and rendering speed of the application. We’re going to discuss many of added benefits in detail throughout the course, so if it doesn’t make sense right now don’t worry.</a:t>
             </a:r>
-            <a:endParaRPr sz="1200"/>
+            <a:endParaRPr sz="1200" dirty="0"/>
           </a:p>
           <a:p>
             <a:pPr marL="0" lvl="0" indent="0" algn="l" rtl="0">
@@ -14982,10 +15010,10 @@
               <a:buNone/>
             </a:pPr>
             <a:r>
-              <a:rPr lang="en" sz="1200"/>
+              <a:rPr lang="en" sz="1200" dirty="0"/>
               <a:t>Added Benefits:</a:t>
             </a:r>
-            <a:endParaRPr sz="1200"/>
+            <a:endParaRPr sz="1200" dirty="0"/>
           </a:p>
           <a:p>
             <a:pPr marL="457200" lvl="0" indent="-304800" algn="l" rtl="0">
@@ -14999,10 +15027,10 @@
               <a:buChar char="●"/>
             </a:pPr>
             <a:r>
-              <a:rPr lang="en" sz="1200"/>
+              <a:rPr lang="en" sz="1200" dirty="0"/>
               <a:t>Server Side Rendering and other Rendering techniques (Such as Pre-rendering/Static Site Generation and Deferred Rendering/Incremental Static Regeneration)</a:t>
             </a:r>
-            <a:endParaRPr sz="1200"/>
+            <a:endParaRPr sz="1200" dirty="0"/>
           </a:p>
           <a:p>
             <a:pPr marL="914400" lvl="1" indent="-304800" algn="l" rtl="0">
@@ -15016,10 +15044,10 @@
               <a:buChar char="○"/>
             </a:pPr>
             <a:r>
-              <a:rPr lang="en" sz="1200"/>
+              <a:rPr lang="en" sz="1200" dirty="0"/>
               <a:t>Gives you the ability to speed up your site</a:t>
             </a:r>
-            <a:endParaRPr sz="1200"/>
+            <a:endParaRPr sz="1200" dirty="0"/>
           </a:p>
           <a:p>
             <a:pPr marL="914400" lvl="1" indent="-304800" algn="l" rtl="0">
@@ -15033,10 +15061,10 @@
               <a:buChar char="○"/>
             </a:pPr>
             <a:r>
-              <a:rPr lang="en" sz="1200"/>
+              <a:rPr lang="en" sz="1200" dirty="0"/>
               <a:t>Gives you out of the box indexable website which is great for SEO</a:t>
             </a:r>
-            <a:endParaRPr sz="1200"/>
+            <a:endParaRPr sz="1200" dirty="0"/>
           </a:p>
           <a:p>
             <a:pPr marL="457200" lvl="0" indent="-304800" algn="l" rtl="0">
@@ -15050,10 +15078,10 @@
               <a:buChar char="●"/>
             </a:pPr>
             <a:r>
-              <a:rPr lang="en" sz="1200"/>
+              <a:rPr lang="en" sz="1200" dirty="0"/>
               <a:t>Automatic Code Splitting</a:t>
             </a:r>
-            <a:endParaRPr sz="1200"/>
+            <a:endParaRPr sz="1200" dirty="0"/>
           </a:p>
           <a:p>
             <a:pPr marL="914400" lvl="1" indent="-304800" algn="l" rtl="0">
@@ -15067,10 +15095,10 @@
               <a:buChar char="○"/>
             </a:pPr>
             <a:r>
-              <a:rPr lang="en" sz="1200"/>
+              <a:rPr lang="en" sz="1200" dirty="0"/>
               <a:t>Next.js is smart enough to split JS and CSS </a:t>
             </a:r>
-            <a:endParaRPr sz="1200"/>
+            <a:endParaRPr sz="1200" dirty="0"/>
           </a:p>
           <a:p>
             <a:pPr marL="457200" lvl="0" indent="-304800" algn="l" rtl="0">
@@ -15084,10 +15112,10 @@
               <a:buChar char="●"/>
             </a:pPr>
             <a:r>
-              <a:rPr lang="en" sz="1200"/>
+              <a:rPr lang="en" sz="1200" dirty="0"/>
               <a:t>Hot Module Replacement (more for devs)</a:t>
             </a:r>
-            <a:endParaRPr sz="1200"/>
+            <a:endParaRPr sz="1200" dirty="0"/>
           </a:p>
           <a:p>
             <a:pPr marL="914400" lvl="1" indent="-304800" algn="l" rtl="0">
@@ -15101,10 +15129,10 @@
               <a:buChar char="○"/>
             </a:pPr>
             <a:r>
-              <a:rPr lang="en" sz="1200"/>
+              <a:rPr lang="en" sz="1200" dirty="0"/>
               <a:t>This gives an environment for devs that when you make a change in your code it is immediately reflected on your environment</a:t>
             </a:r>
-            <a:endParaRPr sz="1200"/>
+            <a:endParaRPr sz="1200" dirty="0"/>
           </a:p>
           <a:p>
             <a:pPr marL="457200" lvl="0" indent="-304800" algn="l" rtl="0">
@@ -15118,10 +15146,10 @@
               <a:buChar char="●"/>
             </a:pPr>
             <a:r>
-              <a:rPr lang="en" sz="1200"/>
+              <a:rPr lang="en" sz="1200" dirty="0"/>
               <a:t>This framework allows you get React projects setup more quickly in general rather than just using React.js without next.</a:t>
             </a:r>
-            <a:endParaRPr sz="1200"/>
+            <a:endParaRPr sz="1200" dirty="0"/>
           </a:p>
           <a:p>
             <a:pPr marL="0" lvl="0" indent="0" algn="l" rtl="0">
@@ -15133,7 +15161,7 @@
               </a:spcAft>
               <a:buNone/>
             </a:pPr>
-            <a:endParaRPr sz="1200"/>
+            <a:endParaRPr sz="1200" dirty="0"/>
           </a:p>
           <a:p>
             <a:pPr marL="0" lvl="0" indent="0" algn="l" rtl="0">
@@ -15145,7 +15173,7 @@
               </a:spcAft>
               <a:buNone/>
             </a:pPr>
-            <a:endParaRPr sz="1200"/>
+            <a:endParaRPr sz="1200" dirty="0"/>
           </a:p>
         </p:txBody>
       </p:sp>

</xml_diff>